<commit_message>
chore: align final SlipFlow branding and verified release artifacts
</commit_message>
<xml_diff>
--- a/docs/presentation/SlipFlow_Presentation.pptx
+++ b/docs/presentation/SlipFlow_Presentation.pptx
@@ -2,24 +2,24 @@
 <file path=ppt/presentation.xml><?xml version="1.0" encoding="utf-8"?>
 <p:presentation xmlns:p="http://schemas.openxmlformats.org/presentationml/2006/main">
   <p:sldMasterIdLst>
-    <p:sldMasterId xmlns:r="http://schemas.openxmlformats.org/officeDocument/2006/relationships" id="2147483648" r:id="Rcf42ace714da4347"/>
+    <p:sldMasterId xmlns:r="http://schemas.openxmlformats.org/officeDocument/2006/relationships" id="2147483648" r:id="Rd2b48034342e4d95"/>
   </p:sldMasterIdLst>
   <p:notesMasterIdLst>
-    <p:notesMasterId xmlns:r="http://schemas.openxmlformats.org/officeDocument/2006/relationships" r:id="Rfa522525648b4196"/>
+    <p:notesMasterId xmlns:r="http://schemas.openxmlformats.org/officeDocument/2006/relationships" r:id="R007eee94ccf1486c"/>
   </p:notesMasterIdLst>
   <p:sldIdLst>
-    <p:sldId xmlns:r="http://schemas.openxmlformats.org/officeDocument/2006/relationships" id="256" r:id="Re244380c47b24c8a"/>
-    <p:sldId xmlns:r="http://schemas.openxmlformats.org/officeDocument/2006/relationships" id="257" r:id="Re63e0bbc4c54463c"/>
-    <p:sldId xmlns:r="http://schemas.openxmlformats.org/officeDocument/2006/relationships" id="258" r:id="R2f7dee90e7724a9b"/>
-    <p:sldId xmlns:r="http://schemas.openxmlformats.org/officeDocument/2006/relationships" id="259" r:id="R72aa6856d0f74a80"/>
-    <p:sldId xmlns:r="http://schemas.openxmlformats.org/officeDocument/2006/relationships" id="260" r:id="R9e2b31d8c5d04d02"/>
-    <p:sldId xmlns:r="http://schemas.openxmlformats.org/officeDocument/2006/relationships" id="261" r:id="R88d0b132bd37414a"/>
-    <p:sldId xmlns:r="http://schemas.openxmlformats.org/officeDocument/2006/relationships" id="262" r:id="Rca4390e48cf74f20"/>
-    <p:sldId xmlns:r="http://schemas.openxmlformats.org/officeDocument/2006/relationships" id="263" r:id="Rd949f6bb089e415e"/>
-    <p:sldId xmlns:r="http://schemas.openxmlformats.org/officeDocument/2006/relationships" id="264" r:id="Rb1fe3d6f4c2e4a7f"/>
-    <p:sldId xmlns:r="http://schemas.openxmlformats.org/officeDocument/2006/relationships" id="265" r:id="R13cce6cefc9e4cf4"/>
-    <p:sldId xmlns:r="http://schemas.openxmlformats.org/officeDocument/2006/relationships" id="266" r:id="R623e5bdd1d88493a"/>
-    <p:sldId xmlns:r="http://schemas.openxmlformats.org/officeDocument/2006/relationships" id="267" r:id="R9b9926b2c1c74c69"/>
+    <p:sldId xmlns:r="http://schemas.openxmlformats.org/officeDocument/2006/relationships" id="256" r:id="R5a606f43e82c4906"/>
+    <p:sldId xmlns:r="http://schemas.openxmlformats.org/officeDocument/2006/relationships" id="257" r:id="R235625552baf468f"/>
+    <p:sldId xmlns:r="http://schemas.openxmlformats.org/officeDocument/2006/relationships" id="258" r:id="Rf85ad78b237f4e2d"/>
+    <p:sldId xmlns:r="http://schemas.openxmlformats.org/officeDocument/2006/relationships" id="259" r:id="Rc054b225a7024eca"/>
+    <p:sldId xmlns:r="http://schemas.openxmlformats.org/officeDocument/2006/relationships" id="260" r:id="R1a37c9759aff416a"/>
+    <p:sldId xmlns:r="http://schemas.openxmlformats.org/officeDocument/2006/relationships" id="261" r:id="R67a57792c6d24d4e"/>
+    <p:sldId xmlns:r="http://schemas.openxmlformats.org/officeDocument/2006/relationships" id="262" r:id="Ra47d3b70a0e848c0"/>
+    <p:sldId xmlns:r="http://schemas.openxmlformats.org/officeDocument/2006/relationships" id="263" r:id="R68e2bda613ab4502"/>
+    <p:sldId xmlns:r="http://schemas.openxmlformats.org/officeDocument/2006/relationships" id="264" r:id="R724d2ce9a463455d"/>
+    <p:sldId xmlns:r="http://schemas.openxmlformats.org/officeDocument/2006/relationships" id="265" r:id="Rb842221da950494a"/>
+    <p:sldId xmlns:r="http://schemas.openxmlformats.org/officeDocument/2006/relationships" id="266" r:id="Raa1db1de5ccf49b0"/>
+    <p:sldId xmlns:r="http://schemas.openxmlformats.org/officeDocument/2006/relationships" id="267" r:id="R7e71b08567b94e99"/>
   </p:sldIdLst>
   <p:sldSz cx="12192000" cy="6858000"/>
   <p:notesSz cx="6858000" cy="9144000"/>
@@ -1270,7 +1270,7 @@
           <p:cNvPr id="3" name="Title">
             <a:extLst xmlns:a="http://schemas.openxmlformats.org/drawingml/2006/main">
               <a:ext uri="{FF2B5EF4-FFF2-40B4-BE49-F238E27FC236}">
-                <a16:creationId xmlns:a16="http://schemas.microsoft.com/office/drawing/2014/main" id="{D798944B-8BD4-4515-92A8-0E5D0D9A6583}"/>
+                <a16:creationId xmlns:a16="http://schemas.microsoft.com/office/drawing/2014/main" id="{333DEAE6-5AE8-40EA-9BAE-7E36D50875B1}"/>
               </a:ext>
             </a:extLst>
           </p:cNvPr>
@@ -1427,7 +1427,7 @@
           <p:cNvPr id="2" name="Subtitle">
             <a:extLst xmlns:a="http://schemas.openxmlformats.org/drawingml/2006/main">
               <a:ext uri="{FF2B5EF4-FFF2-40B4-BE49-F238E27FC236}">
-                <a16:creationId xmlns:a16="http://schemas.microsoft.com/office/drawing/2014/main" id="{2D7CA9E3-B878-461F-B0B1-AEED6520D5BB}"/>
+                <a16:creationId xmlns:a16="http://schemas.microsoft.com/office/drawing/2014/main" id="{F82CE86B-D49C-4065-805E-8D9A8D82B820}"/>
               </a:ext>
             </a:extLst>
           </p:cNvPr>
@@ -1601,7 +1601,7 @@
           <p:cNvPr id="2" name="Section title">
             <a:extLst xmlns:a="http://schemas.openxmlformats.org/drawingml/2006/main">
               <a:ext uri="{FF2B5EF4-FFF2-40B4-BE49-F238E27FC236}">
-                <a16:creationId xmlns:a16="http://schemas.microsoft.com/office/drawing/2014/main" id="{675401D6-D357-4D1D-B06B-B384251C6557}"/>
+                <a16:creationId xmlns:a16="http://schemas.microsoft.com/office/drawing/2014/main" id="{4636A91E-FCA9-4993-BC07-5C983C8084E6}"/>
               </a:ext>
             </a:extLst>
           </p:cNvPr>
@@ -1775,7 +1775,7 @@
           <p:cNvPr id="3" name="Title">
             <a:extLst xmlns:a="http://schemas.openxmlformats.org/drawingml/2006/main">
               <a:ext uri="{FF2B5EF4-FFF2-40B4-BE49-F238E27FC236}">
-                <a16:creationId xmlns:a16="http://schemas.microsoft.com/office/drawing/2014/main" id="{D94B9036-938C-4600-A117-C81EC0B7DFAB}"/>
+                <a16:creationId xmlns:a16="http://schemas.microsoft.com/office/drawing/2014/main" id="{81554D35-E2D6-48D8-B0A4-B724B8C26981}"/>
               </a:ext>
             </a:extLst>
           </p:cNvPr>
@@ -1932,7 +1932,7 @@
           <p:cNvPr id="2" name="Body">
             <a:extLst xmlns:a="http://schemas.openxmlformats.org/drawingml/2006/main">
               <a:ext uri="{FF2B5EF4-FFF2-40B4-BE49-F238E27FC236}">
-                <a16:creationId xmlns:a16="http://schemas.microsoft.com/office/drawing/2014/main" id="{7399F5E1-0164-4568-BE72-570CE042B1FA}"/>
+                <a16:creationId xmlns:a16="http://schemas.microsoft.com/office/drawing/2014/main" id="{D0FC5060-A059-4B42-B1A6-356AD0612103}"/>
               </a:ext>
             </a:extLst>
           </p:cNvPr>
@@ -2106,7 +2106,7 @@
           <p:cNvPr id="4" name="Title">
             <a:extLst xmlns:a="http://schemas.openxmlformats.org/drawingml/2006/main">
               <a:ext uri="{FF2B5EF4-FFF2-40B4-BE49-F238E27FC236}">
-                <a16:creationId xmlns:a16="http://schemas.microsoft.com/office/drawing/2014/main" id="{47B6F74F-395D-487E-BF67-57FF37AD37E7}"/>
+                <a16:creationId xmlns:a16="http://schemas.microsoft.com/office/drawing/2014/main" id="{AEF7DF47-FB7F-45C4-9276-B0343752D1C0}"/>
               </a:ext>
             </a:extLst>
           </p:cNvPr>
@@ -2263,7 +2263,7 @@
           <p:cNvPr id="2" name="Left column">
             <a:extLst xmlns:a="http://schemas.openxmlformats.org/drawingml/2006/main">
               <a:ext uri="{FF2B5EF4-FFF2-40B4-BE49-F238E27FC236}">
-                <a16:creationId xmlns:a16="http://schemas.microsoft.com/office/drawing/2014/main" id="{991E66D3-5A12-4276-AE09-7E737A5FE860}"/>
+                <a16:creationId xmlns:a16="http://schemas.microsoft.com/office/drawing/2014/main" id="{71AC11C1-7E17-4AA2-B9A0-8D79F2C03101}"/>
               </a:ext>
             </a:extLst>
           </p:cNvPr>
@@ -2420,7 +2420,7 @@
           <p:cNvPr id="3" name="Right column">
             <a:extLst xmlns:a="http://schemas.openxmlformats.org/drawingml/2006/main">
               <a:ext uri="{FF2B5EF4-FFF2-40B4-BE49-F238E27FC236}">
-                <a16:creationId xmlns:a16="http://schemas.microsoft.com/office/drawing/2014/main" id="{6BBC80BD-305D-4344-A0F4-E4D5FAB1EE6B}"/>
+                <a16:creationId xmlns:a16="http://schemas.microsoft.com/office/drawing/2014/main" id="{07905C1B-1E3E-4218-8A8B-E0AFA54C7C72}"/>
               </a:ext>
             </a:extLst>
           </p:cNvPr>
@@ -2594,7 +2594,7 @@
           <p:cNvPr id="3" name="Title">
             <a:extLst xmlns:a="http://schemas.openxmlformats.org/drawingml/2006/main">
               <a:ext uri="{FF2B5EF4-FFF2-40B4-BE49-F238E27FC236}">
-                <a16:creationId xmlns:a16="http://schemas.microsoft.com/office/drawing/2014/main" id="{A8B1B4D9-F651-4A3F-B8E6-4FFA1DDE92E3}"/>
+                <a16:creationId xmlns:a16="http://schemas.microsoft.com/office/drawing/2014/main" id="{AF7ED79F-15FE-4FCE-8D2F-40A010816C3A}"/>
               </a:ext>
             </a:extLst>
           </p:cNvPr>
@@ -2751,7 +2751,7 @@
           <p:cNvPr id="2" name="Left column">
             <a:extLst xmlns:a="http://schemas.openxmlformats.org/drawingml/2006/main">
               <a:ext uri="{FF2B5EF4-FFF2-40B4-BE49-F238E27FC236}">
-                <a16:creationId xmlns:a16="http://schemas.microsoft.com/office/drawing/2014/main" id="{BE7BA372-6EA1-439D-97DB-72C84AFB8976}"/>
+                <a16:creationId xmlns:a16="http://schemas.microsoft.com/office/drawing/2014/main" id="{C4944359-D1DA-418A-BECF-C906C68EA056}"/>
               </a:ext>
             </a:extLst>
           </p:cNvPr>
@@ -2946,12 +2946,12 @@
   </p:cSld>
   <p:clrMap bg1="lt1" tx1="dk1" bg2="lt2" tx2="dk2" accent1="accent1" accent2="accent2" accent3="accent3" accent4="accent4" accent5="accent5" accent6="accent6" hlink="hlink" folHlink="folHlink"/>
   <p:sldLayoutIdLst>
-    <p:sldLayoutId xmlns:r="http://schemas.openxmlformats.org/officeDocument/2006/relationships" id="2147483649" r:id="R73565e76de4a4b36"/>
-    <p:sldLayoutId xmlns:r="http://schemas.openxmlformats.org/officeDocument/2006/relationships" id="2147483650" r:id="Re9d0b75dac954534"/>
-    <p:sldLayoutId xmlns:r="http://schemas.openxmlformats.org/officeDocument/2006/relationships" id="2147483651" r:id="Rd62a2d71302f435e"/>
-    <p:sldLayoutId xmlns:r="http://schemas.openxmlformats.org/officeDocument/2006/relationships" id="2147483652" r:id="R3fbb895a37bc4ff0"/>
-    <p:sldLayoutId xmlns:r="http://schemas.openxmlformats.org/officeDocument/2006/relationships" id="2147483653" r:id="Rc6ec26631c164185"/>
-    <p:sldLayoutId xmlns:r="http://schemas.openxmlformats.org/officeDocument/2006/relationships" id="2147483654" r:id="R08af573903cf4ec3"/>
+    <p:sldLayoutId xmlns:r="http://schemas.openxmlformats.org/officeDocument/2006/relationships" id="2147483649" r:id="R9260dca2c1f04bf9"/>
+    <p:sldLayoutId xmlns:r="http://schemas.openxmlformats.org/officeDocument/2006/relationships" id="2147483650" r:id="R0a4fc6ac0a4a437b"/>
+    <p:sldLayoutId xmlns:r="http://schemas.openxmlformats.org/officeDocument/2006/relationships" id="2147483651" r:id="Rae101bce55f94d81"/>
+    <p:sldLayoutId xmlns:r="http://schemas.openxmlformats.org/officeDocument/2006/relationships" id="2147483652" r:id="Rc1aa16bd3f4c45cd"/>
+    <p:sldLayoutId xmlns:r="http://schemas.openxmlformats.org/officeDocument/2006/relationships" id="2147483653" r:id="Rbf8cc9b64ad34c5c"/>
+    <p:sldLayoutId xmlns:r="http://schemas.openxmlformats.org/officeDocument/2006/relationships" id="2147483654" r:id="R52c44296f7af48d4"/>
   </p:sldLayoutIdLst>
   <p:txStyles>
     <p:titleStyle>
@@ -3502,7 +3502,7 @@
           <p:cNvPr id="6" name="">
             <a:extLst xmlns:a="http://schemas.openxmlformats.org/drawingml/2006/main">
               <a:ext uri="{FF2B5EF4-FFF2-40B4-BE49-F238E27FC236}">
-                <a16:creationId xmlns:a16="http://schemas.microsoft.com/office/drawing/2014/main" id="{FED9CAFF-96AA-40F3-B1E3-1080B2F680DB}"/>
+                <a16:creationId xmlns:a16="http://schemas.microsoft.com/office/drawing/2014/main" id="{7C22C63A-C463-4D90-91DF-08C52CF7AC65}"/>
               </a:ext>
             </a:extLst>
           </p:cNvPr>
@@ -3568,7 +3568,7 @@
           <p:cNvPr id="2" name="">
             <a:extLst xmlns:a="http://schemas.openxmlformats.org/drawingml/2006/main">
               <a:ext uri="{FF2B5EF4-FFF2-40B4-BE49-F238E27FC236}">
-                <a16:creationId xmlns:a16="http://schemas.microsoft.com/office/drawing/2014/main" id="{4B77FD5B-9810-4CA9-84A4-9C8E9DE2B6B7}"/>
+                <a16:creationId xmlns:a16="http://schemas.microsoft.com/office/drawing/2014/main" id="{4039C8E1-9C07-471E-8533-B15FB6D284FA}"/>
               </a:ext>
             </a:extLst>
           </p:cNvPr>
@@ -3634,7 +3634,7 @@
           <p:cNvPr id="3" name="">
             <a:extLst xmlns:a="http://schemas.openxmlformats.org/drawingml/2006/main">
               <a:ext uri="{FF2B5EF4-FFF2-40B4-BE49-F238E27FC236}">
-                <a16:creationId xmlns:a16="http://schemas.microsoft.com/office/drawing/2014/main" id="{219C0399-2F51-47B9-AE55-CE8BE3AFE66F}"/>
+                <a16:creationId xmlns:a16="http://schemas.microsoft.com/office/drawing/2014/main" id="{8EEA7159-B5B1-4A6A-B406-7AF27E795FEA}"/>
               </a:ext>
             </a:extLst>
           </p:cNvPr>
@@ -3723,7 +3723,7 @@
           <p:cNvPr id="4" name="">
             <a:extLst xmlns:a="http://schemas.openxmlformats.org/drawingml/2006/main">
               <a:ext uri="{FF2B5EF4-FFF2-40B4-BE49-F238E27FC236}">
-                <a16:creationId xmlns:a16="http://schemas.microsoft.com/office/drawing/2014/main" id="{7F8F7EAE-30EC-4E73-9835-C9A0651167F8}"/>
+                <a16:creationId xmlns:a16="http://schemas.microsoft.com/office/drawing/2014/main" id="{826FCB9E-1334-40AF-AC66-62928619ACCC}"/>
               </a:ext>
             </a:extLst>
           </p:cNvPr>
@@ -3789,7 +3789,7 @@
           <p:cNvPr id="5" name="">
             <a:extLst xmlns:a="http://schemas.openxmlformats.org/drawingml/2006/main">
               <a:ext uri="{FF2B5EF4-FFF2-40B4-BE49-F238E27FC236}">
-                <a16:creationId xmlns:a16="http://schemas.microsoft.com/office/drawing/2014/main" id="{379F528D-6118-4FD5-8EE9-EFC2F3B85256}"/>
+                <a16:creationId xmlns:a16="http://schemas.microsoft.com/office/drawing/2014/main" id="{20EC5810-6564-4A27-8632-313DB55EBCB5}"/>
               </a:ext>
             </a:extLst>
           </p:cNvPr>
@@ -3876,7 +3876,7 @@
     </p:spTree>
     <p:extLst>
       <p:ext uri="{BB962C8B-B14F-4D97-AF65-F5344CB8AC3E}">
-        <p14:creationId xmlns:p14="http://schemas.microsoft.com/office/powerpoint/2010/main" val="519585395"/>
+        <p14:creationId xmlns:p14="http://schemas.microsoft.com/office/powerpoint/2010/main" val="2043823719"/>
       </p:ext>
     </p:extLst>
   </p:cSld>
@@ -3907,7 +3907,7 @@
           <p:cNvPr id="8" name="">
             <a:extLst xmlns:a="http://schemas.openxmlformats.org/drawingml/2006/main">
               <a:ext uri="{FF2B5EF4-FFF2-40B4-BE49-F238E27FC236}">
-                <a16:creationId xmlns:a16="http://schemas.microsoft.com/office/drawing/2014/main" id="{963D1410-7FD0-42F7-A0BC-CB83C7696A98}"/>
+                <a16:creationId xmlns:a16="http://schemas.microsoft.com/office/drawing/2014/main" id="{A4B107FC-ADD7-4647-9D1B-FD6EDC4CACEE}"/>
               </a:ext>
             </a:extLst>
           </p:cNvPr>
@@ -3973,7 +3973,7 @@
           <p:cNvPr id="2" name="">
             <a:extLst xmlns:a="http://schemas.openxmlformats.org/drawingml/2006/main">
               <a:ext uri="{FF2B5EF4-FFF2-40B4-BE49-F238E27FC236}">
-                <a16:creationId xmlns:a16="http://schemas.microsoft.com/office/drawing/2014/main" id="{42024D48-2AF3-4E6D-AB3A-1D73DF22832D}"/>
+                <a16:creationId xmlns:a16="http://schemas.microsoft.com/office/drawing/2014/main" id="{E103847F-6D4D-4513-BE48-8E4C441E29DA}"/>
               </a:ext>
             </a:extLst>
           </p:cNvPr>
@@ -4039,7 +4039,7 @@
           <p:cNvPr id="3" name="">
             <a:extLst xmlns:a="http://schemas.openxmlformats.org/drawingml/2006/main">
               <a:ext uri="{FF2B5EF4-FFF2-40B4-BE49-F238E27FC236}">
-                <a16:creationId xmlns:a16="http://schemas.microsoft.com/office/drawing/2014/main" id="{BAC1A408-FDD0-42BB-906F-283DBA22B4C5}"/>
+                <a16:creationId xmlns:a16="http://schemas.microsoft.com/office/drawing/2014/main" id="{F8091C07-E26F-4D34-87C3-65190A308836}"/>
               </a:ext>
             </a:extLst>
           </p:cNvPr>
@@ -4105,7 +4105,7 @@
           <p:cNvPr id="4" name="">
             <a:extLst xmlns:a="http://schemas.openxmlformats.org/drawingml/2006/main">
               <a:ext uri="{FF2B5EF4-FFF2-40B4-BE49-F238E27FC236}">
-                <a16:creationId xmlns:a16="http://schemas.microsoft.com/office/drawing/2014/main" id="{4CB2FDFF-EFA9-4BF3-8970-EC3A1CE7815C}"/>
+                <a16:creationId xmlns:a16="http://schemas.microsoft.com/office/drawing/2014/main" id="{72A98446-6EE0-4EC6-A1A1-46EBD7231DAB}"/>
               </a:ext>
             </a:extLst>
           </p:cNvPr>
@@ -4171,7 +4171,7 @@
           <p:cNvPr id="5" name="">
             <a:extLst xmlns:a="http://schemas.openxmlformats.org/drawingml/2006/main">
               <a:ext uri="{FF2B5EF4-FFF2-40B4-BE49-F238E27FC236}">
-                <a16:creationId xmlns:a16="http://schemas.microsoft.com/office/drawing/2014/main" id="{F149C306-C93C-4755-B3BB-630AB23E4602}"/>
+                <a16:creationId xmlns:a16="http://schemas.microsoft.com/office/drawing/2014/main" id="{610C42FC-1437-4B0F-922C-3807293C5133}"/>
               </a:ext>
             </a:extLst>
           </p:cNvPr>
@@ -4237,7 +4237,7 @@
           <p:cNvPr id="6" name="">
             <a:extLst xmlns:a="http://schemas.openxmlformats.org/drawingml/2006/main">
               <a:ext uri="{FF2B5EF4-FFF2-40B4-BE49-F238E27FC236}">
-                <a16:creationId xmlns:a16="http://schemas.microsoft.com/office/drawing/2014/main" id="{22A7879D-B619-4652-BFA0-2BF0E48863AE}"/>
+                <a16:creationId xmlns:a16="http://schemas.microsoft.com/office/drawing/2014/main" id="{F2AC3751-631A-4BB4-B98A-843F01E608DA}"/>
               </a:ext>
             </a:extLst>
           </p:cNvPr>
@@ -4303,7 +4303,7 @@
           <p:cNvPr id="7" name="">
             <a:extLst xmlns:a="http://schemas.openxmlformats.org/drawingml/2006/main">
               <a:ext uri="{FF2B5EF4-FFF2-40B4-BE49-F238E27FC236}">
-                <a16:creationId xmlns:a16="http://schemas.microsoft.com/office/drawing/2014/main" id="{9B8FFEDB-4B89-491D-9DCA-824F58C62292}"/>
+                <a16:creationId xmlns:a16="http://schemas.microsoft.com/office/drawing/2014/main" id="{E9CF97E2-9240-444C-A36E-4A5B6819162B}"/>
               </a:ext>
             </a:extLst>
           </p:cNvPr>
@@ -4459,7 +4459,7 @@
     </p:spTree>
     <p:extLst>
       <p:ext uri="{BB962C8B-B14F-4D97-AF65-F5344CB8AC3E}">
-        <p14:creationId xmlns:p14="http://schemas.microsoft.com/office/powerpoint/2010/main" val="1502377036"/>
+        <p14:creationId xmlns:p14="http://schemas.microsoft.com/office/powerpoint/2010/main" val="1302365471"/>
       </p:ext>
     </p:extLst>
   </p:cSld>
@@ -4490,7 +4490,7 @@
           <p:cNvPr id="8" name="">
             <a:extLst xmlns:a="http://schemas.openxmlformats.org/drawingml/2006/main">
               <a:ext uri="{FF2B5EF4-FFF2-40B4-BE49-F238E27FC236}">
-                <a16:creationId xmlns:a16="http://schemas.microsoft.com/office/drawing/2014/main" id="{70616610-3704-49FD-8E2B-87916AA2BA2A}"/>
+                <a16:creationId xmlns:a16="http://schemas.microsoft.com/office/drawing/2014/main" id="{8A6DADCF-1880-407D-8316-564B947778D8}"/>
               </a:ext>
             </a:extLst>
           </p:cNvPr>
@@ -4556,7 +4556,7 @@
           <p:cNvPr id="2" name="">
             <a:extLst xmlns:a="http://schemas.openxmlformats.org/drawingml/2006/main">
               <a:ext uri="{FF2B5EF4-FFF2-40B4-BE49-F238E27FC236}">
-                <a16:creationId xmlns:a16="http://schemas.microsoft.com/office/drawing/2014/main" id="{8F18EAAB-F42F-4246-B557-05783C9331C0}"/>
+                <a16:creationId xmlns:a16="http://schemas.microsoft.com/office/drawing/2014/main" id="{2A72AA6E-9536-4B39-A274-9BED566C32F2}"/>
               </a:ext>
             </a:extLst>
           </p:cNvPr>
@@ -4622,7 +4622,7 @@
           <p:cNvPr id="3" name="">
             <a:extLst xmlns:a="http://schemas.openxmlformats.org/drawingml/2006/main">
               <a:ext uri="{FF2B5EF4-FFF2-40B4-BE49-F238E27FC236}">
-                <a16:creationId xmlns:a16="http://schemas.microsoft.com/office/drawing/2014/main" id="{9AC77B90-64A9-4814-9CC9-F5EC5B8ED52D}"/>
+                <a16:creationId xmlns:a16="http://schemas.microsoft.com/office/drawing/2014/main" id="{7979857D-E7A4-453A-BA9E-50F2CFDABB1E}"/>
               </a:ext>
             </a:extLst>
           </p:cNvPr>
@@ -4688,7 +4688,7 @@
           <p:cNvPr id="4" name="">
             <a:extLst xmlns:a="http://schemas.openxmlformats.org/drawingml/2006/main">
               <a:ext uri="{FF2B5EF4-FFF2-40B4-BE49-F238E27FC236}">
-                <a16:creationId xmlns:a16="http://schemas.microsoft.com/office/drawing/2014/main" id="{D9DFF360-9076-41CA-9418-03F9C26C07B4}"/>
+                <a16:creationId xmlns:a16="http://schemas.microsoft.com/office/drawing/2014/main" id="{2F75AD15-EF1D-48C1-837E-5D82DC6133D5}"/>
               </a:ext>
             </a:extLst>
           </p:cNvPr>
@@ -4823,7 +4823,7 @@
           <p:cNvPr id="5" name="">
             <a:extLst xmlns:a="http://schemas.openxmlformats.org/drawingml/2006/main">
               <a:ext uri="{FF2B5EF4-FFF2-40B4-BE49-F238E27FC236}">
-                <a16:creationId xmlns:a16="http://schemas.microsoft.com/office/drawing/2014/main" id="{3F6E463F-ADC9-46DA-A236-193B79A14FA4}"/>
+                <a16:creationId xmlns:a16="http://schemas.microsoft.com/office/drawing/2014/main" id="{55A784AC-FFAE-4861-B62A-CF648DCBC914}"/>
               </a:ext>
             </a:extLst>
           </p:cNvPr>
@@ -4889,7 +4889,7 @@
           <p:cNvPr id="6" name="">
             <a:extLst xmlns:a="http://schemas.openxmlformats.org/drawingml/2006/main">
               <a:ext uri="{FF2B5EF4-FFF2-40B4-BE49-F238E27FC236}">
-                <a16:creationId xmlns:a16="http://schemas.microsoft.com/office/drawing/2014/main" id="{1DC6D2E7-8D4F-401E-8372-DB5DA429B531}"/>
+                <a16:creationId xmlns:a16="http://schemas.microsoft.com/office/drawing/2014/main" id="{FE11DCC6-F280-4946-B65F-87E39E649152}"/>
               </a:ext>
             </a:extLst>
           </p:cNvPr>
@@ -5024,7 +5024,7 @@
           <p:cNvPr id="7" name="">
             <a:extLst xmlns:a="http://schemas.openxmlformats.org/drawingml/2006/main">
               <a:ext uri="{FF2B5EF4-FFF2-40B4-BE49-F238E27FC236}">
-                <a16:creationId xmlns:a16="http://schemas.microsoft.com/office/drawing/2014/main" id="{501164BE-412B-4115-A2FB-A1E10114E57C}"/>
+                <a16:creationId xmlns:a16="http://schemas.microsoft.com/office/drawing/2014/main" id="{6F5285A7-EBB3-4673-AFEF-46EB3E333A22}"/>
               </a:ext>
             </a:extLst>
           </p:cNvPr>
@@ -5088,7 +5088,7 @@
     </p:spTree>
     <p:extLst>
       <p:ext uri="{BB962C8B-B14F-4D97-AF65-F5344CB8AC3E}">
-        <p14:creationId xmlns:p14="http://schemas.microsoft.com/office/powerpoint/2010/main" val="1310789815"/>
+        <p14:creationId xmlns:p14="http://schemas.microsoft.com/office/powerpoint/2010/main" val="1247098265"/>
       </p:ext>
     </p:extLst>
   </p:cSld>
@@ -5119,7 +5119,7 @@
           <p:cNvPr id="6" name="">
             <a:extLst xmlns:a="http://schemas.openxmlformats.org/drawingml/2006/main">
               <a:ext uri="{FF2B5EF4-FFF2-40B4-BE49-F238E27FC236}">
-                <a16:creationId xmlns:a16="http://schemas.microsoft.com/office/drawing/2014/main" id="{916791C4-5A3F-48A1-BEA9-7B2E11C4ED66}"/>
+                <a16:creationId xmlns:a16="http://schemas.microsoft.com/office/drawing/2014/main" id="{70BC98DE-F7DE-4375-A4F9-144B7DD81BA2}"/>
               </a:ext>
             </a:extLst>
           </p:cNvPr>
@@ -5185,7 +5185,7 @@
           <p:cNvPr id="2" name="">
             <a:extLst xmlns:a="http://schemas.openxmlformats.org/drawingml/2006/main">
               <a:ext uri="{FF2B5EF4-FFF2-40B4-BE49-F238E27FC236}">
-                <a16:creationId xmlns:a16="http://schemas.microsoft.com/office/drawing/2014/main" id="{42BCCC95-3E1E-4AF4-8C26-45624309E716}"/>
+                <a16:creationId xmlns:a16="http://schemas.microsoft.com/office/drawing/2014/main" id="{19D36F63-FAA9-44DC-82BC-7EE449775755}"/>
               </a:ext>
             </a:extLst>
           </p:cNvPr>
@@ -5251,7 +5251,7 @@
           <p:cNvPr id="3" name="">
             <a:extLst xmlns:a="http://schemas.openxmlformats.org/drawingml/2006/main">
               <a:ext uri="{FF2B5EF4-FFF2-40B4-BE49-F238E27FC236}">
-                <a16:creationId xmlns:a16="http://schemas.microsoft.com/office/drawing/2014/main" id="{9E488F45-80BD-47C3-BD9E-A85AFA10621E}"/>
+                <a16:creationId xmlns:a16="http://schemas.microsoft.com/office/drawing/2014/main" id="{529D9928-F181-476A-ADF6-19D64D2BD41B}"/>
               </a:ext>
             </a:extLst>
           </p:cNvPr>
@@ -5261,7 +5261,7 @@
           <p:nvPr/>
         </p:nvPicPr>
         <p:blipFill>
-          <a:blip xmlns:r="http://schemas.openxmlformats.org/officeDocument/2006/relationships" xmlns:a="http://schemas.openxmlformats.org/drawingml/2006/main" r:embed="R2d170d7760d2432b"/>
+          <a:blip xmlns:r="http://schemas.openxmlformats.org/officeDocument/2006/relationships" xmlns:a="http://schemas.openxmlformats.org/drawingml/2006/main" r:embed="R34b329adb0d94c2a"/>
           <a:stretch xmlns:a="http://schemas.openxmlformats.org/drawingml/2006/main"/>
         </p:blipFill>
         <p:spPr>
@@ -5279,7 +5279,7 @@
           <p:cNvPr id="4" name="">
             <a:extLst xmlns:a="http://schemas.openxmlformats.org/drawingml/2006/main">
               <a:ext uri="{FF2B5EF4-FFF2-40B4-BE49-F238E27FC236}">
-                <a16:creationId xmlns:a16="http://schemas.microsoft.com/office/drawing/2014/main" id="{76EAE45A-AD24-45BB-8AD7-2D2DE88FE61A}"/>
+                <a16:creationId xmlns:a16="http://schemas.microsoft.com/office/drawing/2014/main" id="{F322E0B9-2513-4759-B1CD-C592DC29A9F5}"/>
               </a:ext>
             </a:extLst>
           </p:cNvPr>
@@ -5437,7 +5437,7 @@
           <p:cNvPr id="5" name="">
             <a:extLst xmlns:a="http://schemas.openxmlformats.org/drawingml/2006/main">
               <a:ext uri="{FF2B5EF4-FFF2-40B4-BE49-F238E27FC236}">
-                <a16:creationId xmlns:a16="http://schemas.microsoft.com/office/drawing/2014/main" id="{75EAC448-29F8-484A-98DC-D75B6867E45F}"/>
+                <a16:creationId xmlns:a16="http://schemas.microsoft.com/office/drawing/2014/main" id="{C0F7EBE7-7AFC-4143-BA46-EFFDAA1252F6}"/>
               </a:ext>
             </a:extLst>
           </p:cNvPr>
@@ -5501,7 +5501,7 @@
     </p:spTree>
     <p:extLst>
       <p:ext uri="{BB962C8B-B14F-4D97-AF65-F5344CB8AC3E}">
-        <p14:creationId xmlns:p14="http://schemas.microsoft.com/office/powerpoint/2010/main" val="731665016"/>
+        <p14:creationId xmlns:p14="http://schemas.microsoft.com/office/powerpoint/2010/main" val="667910464"/>
       </p:ext>
     </p:extLst>
   </p:cSld>
@@ -5532,7 +5532,7 @@
           <p:cNvPr id="6" name="">
             <a:extLst xmlns:a="http://schemas.openxmlformats.org/drawingml/2006/main">
               <a:ext uri="{FF2B5EF4-FFF2-40B4-BE49-F238E27FC236}">
-                <a16:creationId xmlns:a16="http://schemas.microsoft.com/office/drawing/2014/main" id="{DD739B5C-BC56-401E-8581-596735A60736}"/>
+                <a16:creationId xmlns:a16="http://schemas.microsoft.com/office/drawing/2014/main" id="{387954F7-DEB9-4208-B171-FC7FCFC77E5B}"/>
               </a:ext>
             </a:extLst>
           </p:cNvPr>
@@ -5598,7 +5598,7 @@
           <p:cNvPr id="2" name="">
             <a:extLst xmlns:a="http://schemas.openxmlformats.org/drawingml/2006/main">
               <a:ext uri="{FF2B5EF4-FFF2-40B4-BE49-F238E27FC236}">
-                <a16:creationId xmlns:a16="http://schemas.microsoft.com/office/drawing/2014/main" id="{6930D287-8875-4B2F-9318-05F3A48BB598}"/>
+                <a16:creationId xmlns:a16="http://schemas.microsoft.com/office/drawing/2014/main" id="{97A9210A-133E-4A85-909A-4B8832186B0C}"/>
               </a:ext>
             </a:extLst>
           </p:cNvPr>
@@ -5664,7 +5664,7 @@
           <p:cNvPr id="3" name="">
             <a:extLst xmlns:a="http://schemas.openxmlformats.org/drawingml/2006/main">
               <a:ext uri="{FF2B5EF4-FFF2-40B4-BE49-F238E27FC236}">
-                <a16:creationId xmlns:a16="http://schemas.microsoft.com/office/drawing/2014/main" id="{B65AD7AF-F4CF-40FB-A19C-4F9C0507D0D9}"/>
+                <a16:creationId xmlns:a16="http://schemas.microsoft.com/office/drawing/2014/main" id="{AA0FB8D6-C66E-45FE-BE57-71DAE274D537}"/>
               </a:ext>
             </a:extLst>
           </p:cNvPr>
@@ -5753,7 +5753,7 @@
           <p:cNvPr id="4" name="">
             <a:extLst xmlns:a="http://schemas.openxmlformats.org/drawingml/2006/main">
               <a:ext uri="{FF2B5EF4-FFF2-40B4-BE49-F238E27FC236}">
-                <a16:creationId xmlns:a16="http://schemas.microsoft.com/office/drawing/2014/main" id="{F9AC15EB-20AE-41C9-8A96-B85A43AAE0DF}"/>
+                <a16:creationId xmlns:a16="http://schemas.microsoft.com/office/drawing/2014/main" id="{2E7852DA-B2B2-4E1E-AD4C-BE3B2ADDB390}"/>
               </a:ext>
             </a:extLst>
           </p:cNvPr>
@@ -5819,7 +5819,7 @@
           <p:cNvPr id="5" name="">
             <a:extLst xmlns:a="http://schemas.openxmlformats.org/drawingml/2006/main">
               <a:ext uri="{FF2B5EF4-FFF2-40B4-BE49-F238E27FC236}">
-                <a16:creationId xmlns:a16="http://schemas.microsoft.com/office/drawing/2014/main" id="{84377283-B6C0-4783-A881-04728CEF39E0}"/>
+                <a16:creationId xmlns:a16="http://schemas.microsoft.com/office/drawing/2014/main" id="{9C115703-C788-4520-8643-D0229FF43F11}"/>
               </a:ext>
             </a:extLst>
           </p:cNvPr>
@@ -5829,7 +5829,7 @@
           <p:nvPr/>
         </p:nvPicPr>
         <p:blipFill>
-          <a:blip xmlns:r="http://schemas.openxmlformats.org/officeDocument/2006/relationships" xmlns:a="http://schemas.openxmlformats.org/drawingml/2006/main" r:embed="R57d99e985f69484e"/>
+          <a:blip xmlns:r="http://schemas.openxmlformats.org/officeDocument/2006/relationships" xmlns:a="http://schemas.openxmlformats.org/drawingml/2006/main" r:embed="R4bfbcc38de1f4088"/>
           <a:stretch xmlns:a="http://schemas.openxmlformats.org/drawingml/2006/main"/>
         </p:blipFill>
         <p:spPr>
@@ -5845,7 +5845,7 @@
     </p:spTree>
     <p:extLst>
       <p:ext uri="{BB962C8B-B14F-4D97-AF65-F5344CB8AC3E}">
-        <p14:creationId xmlns:p14="http://schemas.microsoft.com/office/powerpoint/2010/main" val="558611111"/>
+        <p14:creationId xmlns:p14="http://schemas.microsoft.com/office/powerpoint/2010/main" val="273559215"/>
       </p:ext>
     </p:extLst>
   </p:cSld>
@@ -5876,7 +5876,7 @@
           <p:cNvPr id="11" name="">
             <a:extLst xmlns:a="http://schemas.openxmlformats.org/drawingml/2006/main">
               <a:ext uri="{FF2B5EF4-FFF2-40B4-BE49-F238E27FC236}">
-                <a16:creationId xmlns:a16="http://schemas.microsoft.com/office/drawing/2014/main" id="{8CEEFC3A-BB06-4611-9EFF-B48654045CAF}"/>
+                <a16:creationId xmlns:a16="http://schemas.microsoft.com/office/drawing/2014/main" id="{264B2B18-2AA2-4605-B804-4465BD74AB1E}"/>
               </a:ext>
             </a:extLst>
           </p:cNvPr>
@@ -5907,7 +5907,7 @@
           <p:cNvPr id="10" name="">
             <a:extLst xmlns:a="http://schemas.openxmlformats.org/drawingml/2006/main">
               <a:ext uri="{FF2B5EF4-FFF2-40B4-BE49-F238E27FC236}">
-                <a16:creationId xmlns:a16="http://schemas.microsoft.com/office/drawing/2014/main" id="{CB6EAB2C-D2E6-404C-8E1A-BA5AFC395FDB}"/>
+                <a16:creationId xmlns:a16="http://schemas.microsoft.com/office/drawing/2014/main" id="{E5AFA006-E306-48AA-8588-7A2DB1A548B9}"/>
               </a:ext>
             </a:extLst>
           </p:cNvPr>
@@ -5938,7 +5938,7 @@
           <p:cNvPr id="9" name="">
             <a:extLst xmlns:a="http://schemas.openxmlformats.org/drawingml/2006/main">
               <a:ext uri="{FF2B5EF4-FFF2-40B4-BE49-F238E27FC236}">
-                <a16:creationId xmlns:a16="http://schemas.microsoft.com/office/drawing/2014/main" id="{14C32ACE-B3FB-4C95-B529-B969405C1EDC}"/>
+                <a16:creationId xmlns:a16="http://schemas.microsoft.com/office/drawing/2014/main" id="{D9135B9E-B44A-4D6B-9B4E-CC3AD0FBAEB0}"/>
               </a:ext>
             </a:extLst>
           </p:cNvPr>
@@ -5969,7 +5969,7 @@
           <p:cNvPr id="8" name="">
             <a:extLst xmlns:a="http://schemas.openxmlformats.org/drawingml/2006/main">
               <a:ext uri="{FF2B5EF4-FFF2-40B4-BE49-F238E27FC236}">
-                <a16:creationId xmlns:a16="http://schemas.microsoft.com/office/drawing/2014/main" id="{9AFE58BD-D632-49FD-B408-F835D3B0CE02}"/>
+                <a16:creationId xmlns:a16="http://schemas.microsoft.com/office/drawing/2014/main" id="{0C377B2F-78B5-48DD-958A-2775D0BCCBD3}"/>
               </a:ext>
             </a:extLst>
           </p:cNvPr>
@@ -6000,7 +6000,7 @@
           <p:cNvPr id="14" name="">
             <a:extLst xmlns:a="http://schemas.openxmlformats.org/drawingml/2006/main">
               <a:ext uri="{FF2B5EF4-FFF2-40B4-BE49-F238E27FC236}">
-                <a16:creationId xmlns:a16="http://schemas.microsoft.com/office/drawing/2014/main" id="{F7DAD67C-C49A-4B7A-9DC3-4E9F831C7C87}"/>
+                <a16:creationId xmlns:a16="http://schemas.microsoft.com/office/drawing/2014/main" id="{CAE9BF18-A993-4D59-9209-40D723F868D6}"/>
               </a:ext>
             </a:extLst>
           </p:cNvPr>
@@ -6066,7 +6066,7 @@
           <p:cNvPr id="2" name="">
             <a:extLst xmlns:a="http://schemas.openxmlformats.org/drawingml/2006/main">
               <a:ext uri="{FF2B5EF4-FFF2-40B4-BE49-F238E27FC236}">
-                <a16:creationId xmlns:a16="http://schemas.microsoft.com/office/drawing/2014/main" id="{A60E508D-6176-4773-9962-E2769878A2D1}"/>
+                <a16:creationId xmlns:a16="http://schemas.microsoft.com/office/drawing/2014/main" id="{AC7C16BD-7865-4B4B-A68D-60C2155C3AA3}"/>
               </a:ext>
             </a:extLst>
           </p:cNvPr>
@@ -6132,7 +6132,7 @@
           <p:cNvPr id="3" name="">
             <a:extLst xmlns:a="http://schemas.openxmlformats.org/drawingml/2006/main">
               <a:ext uri="{FF2B5EF4-FFF2-40B4-BE49-F238E27FC236}">
-                <a16:creationId xmlns:a16="http://schemas.microsoft.com/office/drawing/2014/main" id="{A82C6507-6FC2-4A40-A0B6-BCEC36498C0F}"/>
+                <a16:creationId xmlns:a16="http://schemas.microsoft.com/office/drawing/2014/main" id="{2CE09BAA-98DF-4C10-A6BC-B58C5397FDBE}"/>
               </a:ext>
             </a:extLst>
           </p:cNvPr>
@@ -6202,7 +6202,7 @@
           <p:cNvPr id="4" name="">
             <a:extLst xmlns:a="http://schemas.openxmlformats.org/drawingml/2006/main">
               <a:ext uri="{FF2B5EF4-FFF2-40B4-BE49-F238E27FC236}">
-                <a16:creationId xmlns:a16="http://schemas.microsoft.com/office/drawing/2014/main" id="{79EA3800-F8B0-44FE-A446-2DEA1DDEF161}"/>
+                <a16:creationId xmlns:a16="http://schemas.microsoft.com/office/drawing/2014/main" id="{2086E8A0-F924-455C-81C0-AA5ECA648049}"/>
               </a:ext>
             </a:extLst>
           </p:cNvPr>
@@ -6272,7 +6272,7 @@
           <p:cNvPr id="5" name="">
             <a:extLst xmlns:a="http://schemas.openxmlformats.org/drawingml/2006/main">
               <a:ext uri="{FF2B5EF4-FFF2-40B4-BE49-F238E27FC236}">
-                <a16:creationId xmlns:a16="http://schemas.microsoft.com/office/drawing/2014/main" id="{94E74449-5223-4E20-8DA6-9106F95874D4}"/>
+                <a16:creationId xmlns:a16="http://schemas.microsoft.com/office/drawing/2014/main" id="{1000C173-FA0F-4A13-9A9A-5FA3316BB095}"/>
               </a:ext>
             </a:extLst>
           </p:cNvPr>
@@ -6342,7 +6342,7 @@
           <p:cNvPr id="6" name="">
             <a:extLst xmlns:a="http://schemas.openxmlformats.org/drawingml/2006/main">
               <a:ext uri="{FF2B5EF4-FFF2-40B4-BE49-F238E27FC236}">
-                <a16:creationId xmlns:a16="http://schemas.microsoft.com/office/drawing/2014/main" id="{75CC06FA-4ECD-4889-9E96-F3A4587C4964}"/>
+                <a16:creationId xmlns:a16="http://schemas.microsoft.com/office/drawing/2014/main" id="{54D4B67F-0F8E-472F-BF71-05ECD4A5C3DE}"/>
               </a:ext>
             </a:extLst>
           </p:cNvPr>
@@ -6412,7 +6412,7 @@
           <p:cNvPr id="7" name="">
             <a:extLst xmlns:a="http://schemas.openxmlformats.org/drawingml/2006/main">
               <a:ext uri="{FF2B5EF4-FFF2-40B4-BE49-F238E27FC236}">
-                <a16:creationId xmlns:a16="http://schemas.microsoft.com/office/drawing/2014/main" id="{03B84A27-611C-4BBE-B596-648339103AAD}"/>
+                <a16:creationId xmlns:a16="http://schemas.microsoft.com/office/drawing/2014/main" id="{5EB2761A-A64F-4D23-BD9F-4783458DEC16}"/>
               </a:ext>
             </a:extLst>
           </p:cNvPr>
@@ -6482,7 +6482,7 @@
           <p:cNvPr id="12" name="">
             <a:extLst xmlns:a="http://schemas.openxmlformats.org/drawingml/2006/main">
               <a:ext uri="{FF2B5EF4-FFF2-40B4-BE49-F238E27FC236}">
-                <a16:creationId xmlns:a16="http://schemas.microsoft.com/office/drawing/2014/main" id="{0E459F05-B6C0-4775-805D-5B442EB08C9D}"/>
+                <a16:creationId xmlns:a16="http://schemas.microsoft.com/office/drawing/2014/main" id="{E5951493-11C3-49CA-AE1C-7226ADE4504B}"/>
               </a:ext>
             </a:extLst>
           </p:cNvPr>
@@ -6548,7 +6548,7 @@
           <p:cNvPr id="13" name="">
             <a:extLst xmlns:a="http://schemas.openxmlformats.org/drawingml/2006/main">
               <a:ext uri="{FF2B5EF4-FFF2-40B4-BE49-F238E27FC236}">
-                <a16:creationId xmlns:a16="http://schemas.microsoft.com/office/drawing/2014/main" id="{E4076878-AEA0-459A-A2BD-EF5DF2F57EF3}"/>
+                <a16:creationId xmlns:a16="http://schemas.microsoft.com/office/drawing/2014/main" id="{644D8D5C-45FF-4AE6-A021-1E4EF625D4B6}"/>
               </a:ext>
             </a:extLst>
           </p:cNvPr>
@@ -6612,7 +6612,7 @@
     </p:spTree>
     <p:extLst>
       <p:ext uri="{BB962C8B-B14F-4D97-AF65-F5344CB8AC3E}">
-        <p14:creationId xmlns:p14="http://schemas.microsoft.com/office/powerpoint/2010/main" val="1005742856"/>
+        <p14:creationId xmlns:p14="http://schemas.microsoft.com/office/powerpoint/2010/main" val="1859570445"/>
       </p:ext>
     </p:extLst>
   </p:cSld>
@@ -6643,7 +6643,7 @@
           <p:cNvPr id="13" name="">
             <a:extLst xmlns:a="http://schemas.openxmlformats.org/drawingml/2006/main">
               <a:ext uri="{FF2B5EF4-FFF2-40B4-BE49-F238E27FC236}">
-                <a16:creationId xmlns:a16="http://schemas.microsoft.com/office/drawing/2014/main" id="{A7F73800-81A5-4B5D-8DFD-E11B0B8F2384}"/>
+                <a16:creationId xmlns:a16="http://schemas.microsoft.com/office/drawing/2014/main" id="{25BC2AAE-0515-448B-980C-8457BDEF6946}"/>
               </a:ext>
             </a:extLst>
           </p:cNvPr>
@@ -6674,7 +6674,7 @@
           <p:cNvPr id="12" name="">
             <a:extLst xmlns:a="http://schemas.openxmlformats.org/drawingml/2006/main">
               <a:ext uri="{FF2B5EF4-FFF2-40B4-BE49-F238E27FC236}">
-                <a16:creationId xmlns:a16="http://schemas.microsoft.com/office/drawing/2014/main" id="{BCAB913D-FF2F-42B0-8902-3432246439EF}"/>
+                <a16:creationId xmlns:a16="http://schemas.microsoft.com/office/drawing/2014/main" id="{6F4FA5FB-8DEC-4EBA-A1B9-195554303911}"/>
               </a:ext>
             </a:extLst>
           </p:cNvPr>
@@ -6705,7 +6705,7 @@
           <p:cNvPr id="11" name="">
             <a:extLst xmlns:a="http://schemas.openxmlformats.org/drawingml/2006/main">
               <a:ext uri="{FF2B5EF4-FFF2-40B4-BE49-F238E27FC236}">
-                <a16:creationId xmlns:a16="http://schemas.microsoft.com/office/drawing/2014/main" id="{F7A66EC7-7CBC-4352-8D6E-E013D43BE3D9}"/>
+                <a16:creationId xmlns:a16="http://schemas.microsoft.com/office/drawing/2014/main" id="{4598D32B-90F4-4628-8C79-55F73179B32E}"/>
               </a:ext>
             </a:extLst>
           </p:cNvPr>
@@ -6736,7 +6736,7 @@
           <p:cNvPr id="10" name="">
             <a:extLst xmlns:a="http://schemas.openxmlformats.org/drawingml/2006/main">
               <a:ext uri="{FF2B5EF4-FFF2-40B4-BE49-F238E27FC236}">
-                <a16:creationId xmlns:a16="http://schemas.microsoft.com/office/drawing/2014/main" id="{C6B8B0AA-7837-4C5F-8EAE-03B17AB88AA8}"/>
+                <a16:creationId xmlns:a16="http://schemas.microsoft.com/office/drawing/2014/main" id="{85630059-4F38-4B80-9EC1-01EE2F8B51D6}"/>
               </a:ext>
             </a:extLst>
           </p:cNvPr>
@@ -6767,7 +6767,7 @@
           <p:cNvPr id="9" name="">
             <a:extLst xmlns:a="http://schemas.openxmlformats.org/drawingml/2006/main">
               <a:ext uri="{FF2B5EF4-FFF2-40B4-BE49-F238E27FC236}">
-                <a16:creationId xmlns:a16="http://schemas.microsoft.com/office/drawing/2014/main" id="{3E23A92B-390B-4200-952D-414E7791C972}"/>
+                <a16:creationId xmlns:a16="http://schemas.microsoft.com/office/drawing/2014/main" id="{4D722D24-9A46-4971-AACE-82588B4DCF36}"/>
               </a:ext>
             </a:extLst>
           </p:cNvPr>
@@ -6798,7 +6798,7 @@
           <p:cNvPr id="15" name="">
             <a:extLst xmlns:a="http://schemas.openxmlformats.org/drawingml/2006/main">
               <a:ext uri="{FF2B5EF4-FFF2-40B4-BE49-F238E27FC236}">
-                <a16:creationId xmlns:a16="http://schemas.microsoft.com/office/drawing/2014/main" id="{FABE3073-1D80-4CB5-B5D9-72AC18979D21}"/>
+                <a16:creationId xmlns:a16="http://schemas.microsoft.com/office/drawing/2014/main" id="{A4DDAE48-9A81-4D59-8726-820F57E06BE2}"/>
               </a:ext>
             </a:extLst>
           </p:cNvPr>
@@ -6864,7 +6864,7 @@
           <p:cNvPr id="2" name="">
             <a:extLst xmlns:a="http://schemas.openxmlformats.org/drawingml/2006/main">
               <a:ext uri="{FF2B5EF4-FFF2-40B4-BE49-F238E27FC236}">
-                <a16:creationId xmlns:a16="http://schemas.microsoft.com/office/drawing/2014/main" id="{2DCB3F62-D9BE-47D3-BAA9-2A9DD61650CC}"/>
+                <a16:creationId xmlns:a16="http://schemas.microsoft.com/office/drawing/2014/main" id="{6B65F2A8-6DF7-4B56-BC20-13FBC63C990F}"/>
               </a:ext>
             </a:extLst>
           </p:cNvPr>
@@ -6930,7 +6930,7 @@
           <p:cNvPr id="3" name="">
             <a:extLst xmlns:a="http://schemas.openxmlformats.org/drawingml/2006/main">
               <a:ext uri="{FF2B5EF4-FFF2-40B4-BE49-F238E27FC236}">
-                <a16:creationId xmlns:a16="http://schemas.microsoft.com/office/drawing/2014/main" id="{96502730-EA8E-4D3E-980D-0232FEB812E4}"/>
+                <a16:creationId xmlns:a16="http://schemas.microsoft.com/office/drawing/2014/main" id="{DD935333-2EB6-4E65-8878-3D497707C36B}"/>
               </a:ext>
             </a:extLst>
           </p:cNvPr>
@@ -7000,7 +7000,7 @@
           <p:cNvPr id="4" name="">
             <a:extLst xmlns:a="http://schemas.openxmlformats.org/drawingml/2006/main">
               <a:ext uri="{FF2B5EF4-FFF2-40B4-BE49-F238E27FC236}">
-                <a16:creationId xmlns:a16="http://schemas.microsoft.com/office/drawing/2014/main" id="{4EF6EE40-130E-4BEC-AE48-824E4F390755}"/>
+                <a16:creationId xmlns:a16="http://schemas.microsoft.com/office/drawing/2014/main" id="{001B656E-F755-4DFA-903D-D281240754E4}"/>
               </a:ext>
             </a:extLst>
           </p:cNvPr>
@@ -7070,7 +7070,7 @@
           <p:cNvPr id="5" name="">
             <a:extLst xmlns:a="http://schemas.openxmlformats.org/drawingml/2006/main">
               <a:ext uri="{FF2B5EF4-FFF2-40B4-BE49-F238E27FC236}">
-                <a16:creationId xmlns:a16="http://schemas.microsoft.com/office/drawing/2014/main" id="{C3EC5073-E371-490A-8777-C178E63CF06C}"/>
+                <a16:creationId xmlns:a16="http://schemas.microsoft.com/office/drawing/2014/main" id="{A9AF3DEE-023C-4580-80A6-AF1082D092FF}"/>
               </a:ext>
             </a:extLst>
           </p:cNvPr>
@@ -7140,7 +7140,7 @@
           <p:cNvPr id="6" name="">
             <a:extLst xmlns:a="http://schemas.openxmlformats.org/drawingml/2006/main">
               <a:ext uri="{FF2B5EF4-FFF2-40B4-BE49-F238E27FC236}">
-                <a16:creationId xmlns:a16="http://schemas.microsoft.com/office/drawing/2014/main" id="{8592679E-0E23-40F8-A7BA-E5BD518D3DDC}"/>
+                <a16:creationId xmlns:a16="http://schemas.microsoft.com/office/drawing/2014/main" id="{E7A1053A-6CBE-4689-A181-06C2A7744348}"/>
               </a:ext>
             </a:extLst>
           </p:cNvPr>
@@ -7210,7 +7210,7 @@
           <p:cNvPr id="7" name="">
             <a:extLst xmlns:a="http://schemas.openxmlformats.org/drawingml/2006/main">
               <a:ext uri="{FF2B5EF4-FFF2-40B4-BE49-F238E27FC236}">
-                <a16:creationId xmlns:a16="http://schemas.microsoft.com/office/drawing/2014/main" id="{F1F52BD9-4409-4CFD-8176-BBEE2BC02115}"/>
+                <a16:creationId xmlns:a16="http://schemas.microsoft.com/office/drawing/2014/main" id="{E8CB1092-5319-4103-8FCD-8AF1A04BE296}"/>
               </a:ext>
             </a:extLst>
           </p:cNvPr>
@@ -7280,7 +7280,7 @@
           <p:cNvPr id="8" name="">
             <a:extLst xmlns:a="http://schemas.openxmlformats.org/drawingml/2006/main">
               <a:ext uri="{FF2B5EF4-FFF2-40B4-BE49-F238E27FC236}">
-                <a16:creationId xmlns:a16="http://schemas.microsoft.com/office/drawing/2014/main" id="{ECE60230-3F26-4359-8F9D-EF6D4A9D5E7E}"/>
+                <a16:creationId xmlns:a16="http://schemas.microsoft.com/office/drawing/2014/main" id="{8BE855BE-9E82-4CC7-B72E-B750B2AF844C}"/>
               </a:ext>
             </a:extLst>
           </p:cNvPr>
@@ -7350,7 +7350,7 @@
           <p:cNvPr id="14" name="">
             <a:extLst xmlns:a="http://schemas.openxmlformats.org/drawingml/2006/main">
               <a:ext uri="{FF2B5EF4-FFF2-40B4-BE49-F238E27FC236}">
-                <a16:creationId xmlns:a16="http://schemas.microsoft.com/office/drawing/2014/main" id="{AF20BA8B-1C98-47D6-8132-3A92E8A6337D}"/>
+                <a16:creationId xmlns:a16="http://schemas.microsoft.com/office/drawing/2014/main" id="{09B05C9D-8030-4D5B-A20C-C65C34331773}"/>
               </a:ext>
             </a:extLst>
           </p:cNvPr>
@@ -7414,7 +7414,7 @@
     </p:spTree>
     <p:extLst>
       <p:ext uri="{BB962C8B-B14F-4D97-AF65-F5344CB8AC3E}">
-        <p14:creationId xmlns:p14="http://schemas.microsoft.com/office/powerpoint/2010/main" val="1440587934"/>
+        <p14:creationId xmlns:p14="http://schemas.microsoft.com/office/powerpoint/2010/main" val="883862932"/>
       </p:ext>
     </p:extLst>
   </p:cSld>
@@ -7445,7 +7445,7 @@
           <p:cNvPr id="8" name="">
             <a:extLst xmlns:a="http://schemas.openxmlformats.org/drawingml/2006/main">
               <a:ext uri="{FF2B5EF4-FFF2-40B4-BE49-F238E27FC236}">
-                <a16:creationId xmlns:a16="http://schemas.microsoft.com/office/drawing/2014/main" id="{B16C8B63-7236-414F-BD80-1FB61EABFD1C}"/>
+                <a16:creationId xmlns:a16="http://schemas.microsoft.com/office/drawing/2014/main" id="{0D42A339-84DB-4076-A13F-C9764607ABC2}"/>
               </a:ext>
             </a:extLst>
           </p:cNvPr>
@@ -7511,7 +7511,7 @@
           <p:cNvPr id="2" name="">
             <a:extLst xmlns:a="http://schemas.openxmlformats.org/drawingml/2006/main">
               <a:ext uri="{FF2B5EF4-FFF2-40B4-BE49-F238E27FC236}">
-                <a16:creationId xmlns:a16="http://schemas.microsoft.com/office/drawing/2014/main" id="{026BCFCC-00CB-47D2-A32B-748E70C92783}"/>
+                <a16:creationId xmlns:a16="http://schemas.microsoft.com/office/drawing/2014/main" id="{9016D15E-38AA-48C1-B308-8B4693CEC487}"/>
               </a:ext>
             </a:extLst>
           </p:cNvPr>
@@ -7577,7 +7577,7 @@
           <p:cNvPr id="3" name="">
             <a:extLst xmlns:a="http://schemas.openxmlformats.org/drawingml/2006/main">
               <a:ext uri="{FF2B5EF4-FFF2-40B4-BE49-F238E27FC236}">
-                <a16:creationId xmlns:a16="http://schemas.microsoft.com/office/drawing/2014/main" id="{1AF0C188-AADF-43D4-9720-8BE1C00AB833}"/>
+                <a16:creationId xmlns:a16="http://schemas.microsoft.com/office/drawing/2014/main" id="{487F7E96-4066-4F21-8750-0A5DDDF5A903}"/>
               </a:ext>
             </a:extLst>
           </p:cNvPr>
@@ -7643,7 +7643,7 @@
           <p:cNvPr id="4" name="">
             <a:extLst xmlns:a="http://schemas.openxmlformats.org/drawingml/2006/main">
               <a:ext uri="{FF2B5EF4-FFF2-40B4-BE49-F238E27FC236}">
-                <a16:creationId xmlns:a16="http://schemas.microsoft.com/office/drawing/2014/main" id="{4383DA25-160C-45A6-BBF2-01C020E7D750}"/>
+                <a16:creationId xmlns:a16="http://schemas.microsoft.com/office/drawing/2014/main" id="{F7C711DC-42D2-4370-8084-EA1ED0AAD5D1}"/>
               </a:ext>
             </a:extLst>
           </p:cNvPr>
@@ -7778,7 +7778,7 @@
           <p:cNvPr id="5" name="">
             <a:extLst xmlns:a="http://schemas.openxmlformats.org/drawingml/2006/main">
               <a:ext uri="{FF2B5EF4-FFF2-40B4-BE49-F238E27FC236}">
-                <a16:creationId xmlns:a16="http://schemas.microsoft.com/office/drawing/2014/main" id="{AD40C3A5-3D37-4F0D-BFD9-824861BBACB0}"/>
+                <a16:creationId xmlns:a16="http://schemas.microsoft.com/office/drawing/2014/main" id="{2118CE7D-86E5-4F6E-AD4A-DED5DAFD4EF1}"/>
               </a:ext>
             </a:extLst>
           </p:cNvPr>
@@ -7844,7 +7844,7 @@
           <p:cNvPr id="6" name="">
             <a:extLst xmlns:a="http://schemas.openxmlformats.org/drawingml/2006/main">
               <a:ext uri="{FF2B5EF4-FFF2-40B4-BE49-F238E27FC236}">
-                <a16:creationId xmlns:a16="http://schemas.microsoft.com/office/drawing/2014/main" id="{D7C64DB1-22E9-4A9D-9E24-E33C02FECC24}"/>
+                <a16:creationId xmlns:a16="http://schemas.microsoft.com/office/drawing/2014/main" id="{7AF74A0F-DC9C-4EA1-92B5-6F7C8A8815B8}"/>
               </a:ext>
             </a:extLst>
           </p:cNvPr>
@@ -7979,7 +7979,7 @@
           <p:cNvPr id="7" name="">
             <a:extLst xmlns:a="http://schemas.openxmlformats.org/drawingml/2006/main">
               <a:ext uri="{FF2B5EF4-FFF2-40B4-BE49-F238E27FC236}">
-                <a16:creationId xmlns:a16="http://schemas.microsoft.com/office/drawing/2014/main" id="{725FAA02-1BC4-4DE2-B113-CAE712BF673A}"/>
+                <a16:creationId xmlns:a16="http://schemas.microsoft.com/office/drawing/2014/main" id="{007C5683-2E60-4DAA-95FC-A94C36792151}"/>
               </a:ext>
             </a:extLst>
           </p:cNvPr>
@@ -8043,7 +8043,7 @@
     </p:spTree>
     <p:extLst>
       <p:ext uri="{BB962C8B-B14F-4D97-AF65-F5344CB8AC3E}">
-        <p14:creationId xmlns:p14="http://schemas.microsoft.com/office/powerpoint/2010/main" val="49234393"/>
+        <p14:creationId xmlns:p14="http://schemas.microsoft.com/office/powerpoint/2010/main" val="418624644"/>
       </p:ext>
     </p:extLst>
   </p:cSld>
@@ -8074,7 +8074,7 @@
           <p:cNvPr id="6" name="">
             <a:extLst xmlns:a="http://schemas.openxmlformats.org/drawingml/2006/main">
               <a:ext uri="{FF2B5EF4-FFF2-40B4-BE49-F238E27FC236}">
-                <a16:creationId xmlns:a16="http://schemas.microsoft.com/office/drawing/2014/main" id="{4B0B529A-76C8-458F-BB2F-3229D3DBD5F3}"/>
+                <a16:creationId xmlns:a16="http://schemas.microsoft.com/office/drawing/2014/main" id="{75DF1375-3666-450F-80A3-144602C5A1EA}"/>
               </a:ext>
             </a:extLst>
           </p:cNvPr>
@@ -8140,7 +8140,7 @@
           <p:cNvPr id="2" name="">
             <a:extLst xmlns:a="http://schemas.openxmlformats.org/drawingml/2006/main">
               <a:ext uri="{FF2B5EF4-FFF2-40B4-BE49-F238E27FC236}">
-                <a16:creationId xmlns:a16="http://schemas.microsoft.com/office/drawing/2014/main" id="{953AAB76-D55C-4B72-B00C-CA8498DC90C8}"/>
+                <a16:creationId xmlns:a16="http://schemas.microsoft.com/office/drawing/2014/main" id="{D80B1F44-99BD-442F-8410-FFE89277A281}"/>
               </a:ext>
             </a:extLst>
           </p:cNvPr>
@@ -8206,7 +8206,7 @@
           <p:cNvPr id="3" name="">
             <a:extLst xmlns:a="http://schemas.openxmlformats.org/drawingml/2006/main">
               <a:ext uri="{FF2B5EF4-FFF2-40B4-BE49-F238E27FC236}">
-                <a16:creationId xmlns:a16="http://schemas.microsoft.com/office/drawing/2014/main" id="{3631DAB0-C6B0-4FF6-9032-5B1A559F891F}"/>
+                <a16:creationId xmlns:a16="http://schemas.microsoft.com/office/drawing/2014/main" id="{47291589-4703-40E8-8EFB-84DD275C9253}"/>
               </a:ext>
             </a:extLst>
           </p:cNvPr>
@@ -8216,7 +8216,7 @@
           <p:nvPr/>
         </p:nvPicPr>
         <p:blipFill>
-          <a:blip xmlns:r="http://schemas.openxmlformats.org/officeDocument/2006/relationships" xmlns:a="http://schemas.openxmlformats.org/drawingml/2006/main" r:embed="R53cde024260c42ec"/>
+          <a:blip xmlns:r="http://schemas.openxmlformats.org/officeDocument/2006/relationships" xmlns:a="http://schemas.openxmlformats.org/drawingml/2006/main" r:embed="R1524fba2d7e04f3e"/>
           <a:stretch xmlns:a="http://schemas.openxmlformats.org/drawingml/2006/main"/>
         </p:blipFill>
         <p:spPr>
@@ -8234,7 +8234,7 @@
           <p:cNvPr id="4" name="">
             <a:extLst xmlns:a="http://schemas.openxmlformats.org/drawingml/2006/main">
               <a:ext uri="{FF2B5EF4-FFF2-40B4-BE49-F238E27FC236}">
-                <a16:creationId xmlns:a16="http://schemas.microsoft.com/office/drawing/2014/main" id="{37A79B0C-9DBB-4991-84BD-50200DEA0DAD}"/>
+                <a16:creationId xmlns:a16="http://schemas.microsoft.com/office/drawing/2014/main" id="{EDEACE29-B2C2-4BB7-B8C2-2D42DB36F2AA}"/>
               </a:ext>
             </a:extLst>
           </p:cNvPr>
@@ -8300,7 +8300,7 @@
           <p:cNvPr id="5" name="">
             <a:extLst xmlns:a="http://schemas.openxmlformats.org/drawingml/2006/main">
               <a:ext uri="{FF2B5EF4-FFF2-40B4-BE49-F238E27FC236}">
-                <a16:creationId xmlns:a16="http://schemas.microsoft.com/office/drawing/2014/main" id="{4D8F693C-6A71-479F-A0CE-1F6F828BE96C}"/>
+                <a16:creationId xmlns:a16="http://schemas.microsoft.com/office/drawing/2014/main" id="{C3D26614-3C13-4AB9-9BD0-CE5B13A80BA0}"/>
               </a:ext>
             </a:extLst>
           </p:cNvPr>
@@ -8433,7 +8433,7 @@
     </p:spTree>
     <p:extLst>
       <p:ext uri="{BB962C8B-B14F-4D97-AF65-F5344CB8AC3E}">
-        <p14:creationId xmlns:p14="http://schemas.microsoft.com/office/powerpoint/2010/main" val="1614632045"/>
+        <p14:creationId xmlns:p14="http://schemas.microsoft.com/office/powerpoint/2010/main" val="1721106324"/>
       </p:ext>
     </p:extLst>
   </p:cSld>
@@ -8464,7 +8464,7 @@
           <p:cNvPr id="12" name="">
             <a:extLst xmlns:a="http://schemas.openxmlformats.org/drawingml/2006/main">
               <a:ext uri="{FF2B5EF4-FFF2-40B4-BE49-F238E27FC236}">
-                <a16:creationId xmlns:a16="http://schemas.microsoft.com/office/drawing/2014/main" id="{83B97A5F-37B9-454C-9FCB-A8E3B7CDB286}"/>
+                <a16:creationId xmlns:a16="http://schemas.microsoft.com/office/drawing/2014/main" id="{8732A5E3-ABD0-4F89-AA6E-BDEFA9F4963D}"/>
               </a:ext>
             </a:extLst>
           </p:cNvPr>
@@ -8495,7 +8495,7 @@
           <p:cNvPr id="7" name="">
             <a:extLst xmlns:a="http://schemas.openxmlformats.org/drawingml/2006/main">
               <a:ext uri="{FF2B5EF4-FFF2-40B4-BE49-F238E27FC236}">
-                <a16:creationId xmlns:a16="http://schemas.microsoft.com/office/drawing/2014/main" id="{7019E1B4-7E75-47D6-8BA3-B200335C7877}"/>
+                <a16:creationId xmlns:a16="http://schemas.microsoft.com/office/drawing/2014/main" id="{3B6A1D4C-F192-449E-93AC-486DB3AC5BFF}"/>
               </a:ext>
             </a:extLst>
           </p:cNvPr>
@@ -8526,7 +8526,7 @@
           <p:cNvPr id="6" name="">
             <a:extLst xmlns:a="http://schemas.openxmlformats.org/drawingml/2006/main">
               <a:ext uri="{FF2B5EF4-FFF2-40B4-BE49-F238E27FC236}">
-                <a16:creationId xmlns:a16="http://schemas.microsoft.com/office/drawing/2014/main" id="{494A3170-2935-4856-B4C8-4D602009BBD0}"/>
+                <a16:creationId xmlns:a16="http://schemas.microsoft.com/office/drawing/2014/main" id="{66D79B77-7FD3-4F93-BFD6-26FB159D76DC}"/>
               </a:ext>
             </a:extLst>
           </p:cNvPr>
@@ -8557,7 +8557,7 @@
           <p:cNvPr id="14" name="">
             <a:extLst xmlns:a="http://schemas.openxmlformats.org/drawingml/2006/main">
               <a:ext uri="{FF2B5EF4-FFF2-40B4-BE49-F238E27FC236}">
-                <a16:creationId xmlns:a16="http://schemas.microsoft.com/office/drawing/2014/main" id="{EA9994B9-1649-4DA3-A6F2-01FC6F14677C}"/>
+                <a16:creationId xmlns:a16="http://schemas.microsoft.com/office/drawing/2014/main" id="{55A2CFA8-1831-4ABB-945C-9E94CF7218BF}"/>
               </a:ext>
             </a:extLst>
           </p:cNvPr>
@@ -8623,7 +8623,7 @@
           <p:cNvPr id="2" name="">
             <a:extLst xmlns:a="http://schemas.openxmlformats.org/drawingml/2006/main">
               <a:ext uri="{FF2B5EF4-FFF2-40B4-BE49-F238E27FC236}">
-                <a16:creationId xmlns:a16="http://schemas.microsoft.com/office/drawing/2014/main" id="{F216F55B-0012-426D-90D6-EE2E34690BFC}"/>
+                <a16:creationId xmlns:a16="http://schemas.microsoft.com/office/drawing/2014/main" id="{45D0E7D3-03F8-46DB-AAD9-1DCB64C9B9FB}"/>
               </a:ext>
             </a:extLst>
           </p:cNvPr>
@@ -8689,7 +8689,7 @@
           <p:cNvPr id="3" name="">
             <a:extLst xmlns:a="http://schemas.openxmlformats.org/drawingml/2006/main">
               <a:ext uri="{FF2B5EF4-FFF2-40B4-BE49-F238E27FC236}">
-                <a16:creationId xmlns:a16="http://schemas.microsoft.com/office/drawing/2014/main" id="{71D96959-FFF2-4B6F-99DC-7A28D08DE416}"/>
+                <a16:creationId xmlns:a16="http://schemas.microsoft.com/office/drawing/2014/main" id="{9F22F2F4-D894-44D8-9EBD-AFE8EE8224E9}"/>
               </a:ext>
             </a:extLst>
           </p:cNvPr>
@@ -8759,7 +8759,7 @@
           <p:cNvPr id="4" name="">
             <a:extLst xmlns:a="http://schemas.openxmlformats.org/drawingml/2006/main">
               <a:ext uri="{FF2B5EF4-FFF2-40B4-BE49-F238E27FC236}">
-                <a16:creationId xmlns:a16="http://schemas.microsoft.com/office/drawing/2014/main" id="{E5152D6A-2FD7-4B37-AAC6-D2B6B963F969}"/>
+                <a16:creationId xmlns:a16="http://schemas.microsoft.com/office/drawing/2014/main" id="{B0B12600-8FE5-4DAC-81C6-B62476119D8A}"/>
               </a:ext>
             </a:extLst>
           </p:cNvPr>
@@ -8829,7 +8829,7 @@
           <p:cNvPr id="5" name="">
             <a:extLst xmlns:a="http://schemas.openxmlformats.org/drawingml/2006/main">
               <a:ext uri="{FF2B5EF4-FFF2-40B4-BE49-F238E27FC236}">
-                <a16:creationId xmlns:a16="http://schemas.microsoft.com/office/drawing/2014/main" id="{A9A73AD4-81FA-4A41-8C19-372ECF9941C5}"/>
+                <a16:creationId xmlns:a16="http://schemas.microsoft.com/office/drawing/2014/main" id="{A8CD7C2D-3EA5-4B1F-8F9E-8F96A9E517A4}"/>
               </a:ext>
             </a:extLst>
           </p:cNvPr>
@@ -8899,7 +8899,7 @@
           <p:cNvPr id="8" name="">
             <a:extLst xmlns:a="http://schemas.openxmlformats.org/drawingml/2006/main">
               <a:ext uri="{FF2B5EF4-FFF2-40B4-BE49-F238E27FC236}">
-                <a16:creationId xmlns:a16="http://schemas.microsoft.com/office/drawing/2014/main" id="{1547C0D4-0BEC-46DA-A3E3-748AD13C309D}"/>
+                <a16:creationId xmlns:a16="http://schemas.microsoft.com/office/drawing/2014/main" id="{68DE83A7-56E4-428D-9DA3-368A7D8ABAF8}"/>
               </a:ext>
             </a:extLst>
           </p:cNvPr>
@@ -8965,7 +8965,7 @@
           <p:cNvPr id="9" name="">
             <a:extLst xmlns:a="http://schemas.openxmlformats.org/drawingml/2006/main">
               <a:ext uri="{FF2B5EF4-FFF2-40B4-BE49-F238E27FC236}">
-                <a16:creationId xmlns:a16="http://schemas.microsoft.com/office/drawing/2014/main" id="{5878C30A-4114-48A7-8FC2-DE5858EEDBD8}"/>
+                <a16:creationId xmlns:a16="http://schemas.microsoft.com/office/drawing/2014/main" id="{E2F2B013-4EB8-412D-A95D-3BD503C8626B}"/>
               </a:ext>
             </a:extLst>
           </p:cNvPr>
@@ -9031,7 +9031,7 @@
           <p:cNvPr id="10" name="">
             <a:extLst xmlns:a="http://schemas.openxmlformats.org/drawingml/2006/main">
               <a:ext uri="{FF2B5EF4-FFF2-40B4-BE49-F238E27FC236}">
-                <a16:creationId xmlns:a16="http://schemas.microsoft.com/office/drawing/2014/main" id="{58B02A89-EC8D-4A79-9811-8B7E8474DBF8}"/>
+                <a16:creationId xmlns:a16="http://schemas.microsoft.com/office/drawing/2014/main" id="{A3D6DFD1-A560-4FEB-92B3-0777D0930BC1}"/>
               </a:ext>
             </a:extLst>
           </p:cNvPr>
@@ -9097,7 +9097,7 @@
           <p:cNvPr id="11" name="">
             <a:extLst xmlns:a="http://schemas.openxmlformats.org/drawingml/2006/main">
               <a:ext uri="{FF2B5EF4-FFF2-40B4-BE49-F238E27FC236}">
-                <a16:creationId xmlns:a16="http://schemas.microsoft.com/office/drawing/2014/main" id="{7CC3F3BE-1C3A-4A62-A418-52033FA3BC62}"/>
+                <a16:creationId xmlns:a16="http://schemas.microsoft.com/office/drawing/2014/main" id="{D51A0AC6-599D-4F6A-8247-8B91E1BDCE67}"/>
               </a:ext>
             </a:extLst>
           </p:cNvPr>
@@ -9167,7 +9167,7 @@
           <p:cNvPr id="13" name="">
             <a:extLst xmlns:a="http://schemas.openxmlformats.org/drawingml/2006/main">
               <a:ext uri="{FF2B5EF4-FFF2-40B4-BE49-F238E27FC236}">
-                <a16:creationId xmlns:a16="http://schemas.microsoft.com/office/drawing/2014/main" id="{4ADEB56B-2284-4864-BD98-92DA3D126646}"/>
+                <a16:creationId xmlns:a16="http://schemas.microsoft.com/office/drawing/2014/main" id="{0D810CFB-35BE-4E86-9FD7-CEC30F2EE2E3}"/>
               </a:ext>
             </a:extLst>
           </p:cNvPr>
@@ -9254,7 +9254,7 @@
     </p:spTree>
     <p:extLst>
       <p:ext uri="{BB962C8B-B14F-4D97-AF65-F5344CB8AC3E}">
-        <p14:creationId xmlns:p14="http://schemas.microsoft.com/office/powerpoint/2010/main" val="1777990677"/>
+        <p14:creationId xmlns:p14="http://schemas.microsoft.com/office/powerpoint/2010/main" val="407145164"/>
       </p:ext>
     </p:extLst>
   </p:cSld>
@@ -9285,7 +9285,7 @@
           <p:cNvPr id="13" name="">
             <a:extLst xmlns:a="http://schemas.openxmlformats.org/drawingml/2006/main">
               <a:ext uri="{FF2B5EF4-FFF2-40B4-BE49-F238E27FC236}">
-                <a16:creationId xmlns:a16="http://schemas.microsoft.com/office/drawing/2014/main" id="{5C5DEF2A-7C6C-4DA3-9784-939EE9A3007C}"/>
+                <a16:creationId xmlns:a16="http://schemas.microsoft.com/office/drawing/2014/main" id="{53E96B74-2686-499E-876B-921A5163C5EF}"/>
               </a:ext>
             </a:extLst>
           </p:cNvPr>
@@ -9316,7 +9316,7 @@
           <p:cNvPr id="12" name="">
             <a:extLst xmlns:a="http://schemas.openxmlformats.org/drawingml/2006/main">
               <a:ext uri="{FF2B5EF4-FFF2-40B4-BE49-F238E27FC236}">
-                <a16:creationId xmlns:a16="http://schemas.microsoft.com/office/drawing/2014/main" id="{6B602253-B285-4BF7-99CC-46681DDE6D5D}"/>
+                <a16:creationId xmlns:a16="http://schemas.microsoft.com/office/drawing/2014/main" id="{9EA5E07E-65E3-4F66-8EBD-55CB1B51085E}"/>
               </a:ext>
             </a:extLst>
           </p:cNvPr>
@@ -9347,7 +9347,7 @@
           <p:cNvPr id="11" name="">
             <a:extLst xmlns:a="http://schemas.openxmlformats.org/drawingml/2006/main">
               <a:ext uri="{FF2B5EF4-FFF2-40B4-BE49-F238E27FC236}">
-                <a16:creationId xmlns:a16="http://schemas.microsoft.com/office/drawing/2014/main" id="{EE383BD9-B5F6-4313-AF89-D2A893671681}"/>
+                <a16:creationId xmlns:a16="http://schemas.microsoft.com/office/drawing/2014/main" id="{2FBC3F3B-E4F7-4794-B02B-2DF906465F71}"/>
               </a:ext>
             </a:extLst>
           </p:cNvPr>
@@ -9378,7 +9378,7 @@
           <p:cNvPr id="7" name="">
             <a:extLst xmlns:a="http://schemas.openxmlformats.org/drawingml/2006/main">
               <a:ext uri="{FF2B5EF4-FFF2-40B4-BE49-F238E27FC236}">
-                <a16:creationId xmlns:a16="http://schemas.microsoft.com/office/drawing/2014/main" id="{21EF92B2-CD40-4A62-AC4E-6A97484FE7DB}"/>
+                <a16:creationId xmlns:a16="http://schemas.microsoft.com/office/drawing/2014/main" id="{5DA35A30-B1BA-4798-A3EA-34D503D5C17E}"/>
               </a:ext>
             </a:extLst>
           </p:cNvPr>
@@ -9409,7 +9409,7 @@
           <p:cNvPr id="6" name="">
             <a:extLst xmlns:a="http://schemas.openxmlformats.org/drawingml/2006/main">
               <a:ext uri="{FF2B5EF4-FFF2-40B4-BE49-F238E27FC236}">
-                <a16:creationId xmlns:a16="http://schemas.microsoft.com/office/drawing/2014/main" id="{23C9E1C0-8A28-41AA-BF89-CD7D50D0E5DB}"/>
+                <a16:creationId xmlns:a16="http://schemas.microsoft.com/office/drawing/2014/main" id="{BF0F028C-8131-42FB-993B-51BE91D4DECD}"/>
               </a:ext>
             </a:extLst>
           </p:cNvPr>
@@ -9440,7 +9440,7 @@
           <p:cNvPr id="18" name="">
             <a:extLst xmlns:a="http://schemas.openxmlformats.org/drawingml/2006/main">
               <a:ext uri="{FF2B5EF4-FFF2-40B4-BE49-F238E27FC236}">
-                <a16:creationId xmlns:a16="http://schemas.microsoft.com/office/drawing/2014/main" id="{80306C6A-6DE6-4CCD-A996-89A208F13F02}"/>
+                <a16:creationId xmlns:a16="http://schemas.microsoft.com/office/drawing/2014/main" id="{E8DD1EAB-185C-40E9-93F7-29F3C41801C7}"/>
               </a:ext>
             </a:extLst>
           </p:cNvPr>
@@ -9506,7 +9506,7 @@
           <p:cNvPr id="2" name="">
             <a:extLst xmlns:a="http://schemas.openxmlformats.org/drawingml/2006/main">
               <a:ext uri="{FF2B5EF4-FFF2-40B4-BE49-F238E27FC236}">
-                <a16:creationId xmlns:a16="http://schemas.microsoft.com/office/drawing/2014/main" id="{C2269BB0-E925-4A89-B49A-78F33AB538C6}"/>
+                <a16:creationId xmlns:a16="http://schemas.microsoft.com/office/drawing/2014/main" id="{BF859DD4-873F-41A2-BF77-22EED5C78E2A}"/>
               </a:ext>
             </a:extLst>
           </p:cNvPr>
@@ -9572,7 +9572,7 @@
           <p:cNvPr id="3" name="">
             <a:extLst xmlns:a="http://schemas.openxmlformats.org/drawingml/2006/main">
               <a:ext uri="{FF2B5EF4-FFF2-40B4-BE49-F238E27FC236}">
-                <a16:creationId xmlns:a16="http://schemas.microsoft.com/office/drawing/2014/main" id="{72812869-E531-4D39-9B28-5CDF9E56BF6A}"/>
+                <a16:creationId xmlns:a16="http://schemas.microsoft.com/office/drawing/2014/main" id="{6FA3F0EA-6218-45D4-A605-FD3D4C246F36}"/>
               </a:ext>
             </a:extLst>
           </p:cNvPr>
@@ -9642,7 +9642,7 @@
           <p:cNvPr id="4" name="">
             <a:extLst xmlns:a="http://schemas.openxmlformats.org/drawingml/2006/main">
               <a:ext uri="{FF2B5EF4-FFF2-40B4-BE49-F238E27FC236}">
-                <a16:creationId xmlns:a16="http://schemas.microsoft.com/office/drawing/2014/main" id="{2AE82587-6E08-43E2-BD71-9E24C4805805}"/>
+                <a16:creationId xmlns:a16="http://schemas.microsoft.com/office/drawing/2014/main" id="{0A8F90D6-FC0A-4CF5-A6E4-2C32F3334CB3}"/>
               </a:ext>
             </a:extLst>
           </p:cNvPr>
@@ -9712,7 +9712,7 @@
           <p:cNvPr id="5" name="">
             <a:extLst xmlns:a="http://schemas.openxmlformats.org/drawingml/2006/main">
               <a:ext uri="{FF2B5EF4-FFF2-40B4-BE49-F238E27FC236}">
-                <a16:creationId xmlns:a16="http://schemas.microsoft.com/office/drawing/2014/main" id="{CFCA7866-81B9-4DD8-8A60-BECEB30AFB0B}"/>
+                <a16:creationId xmlns:a16="http://schemas.microsoft.com/office/drawing/2014/main" id="{B7723F62-A979-4034-B7EA-672BB614E8E9}"/>
               </a:ext>
             </a:extLst>
           </p:cNvPr>
@@ -9782,7 +9782,7 @@
           <p:cNvPr id="8" name="">
             <a:extLst xmlns:a="http://schemas.openxmlformats.org/drawingml/2006/main">
               <a:ext uri="{FF2B5EF4-FFF2-40B4-BE49-F238E27FC236}">
-                <a16:creationId xmlns:a16="http://schemas.microsoft.com/office/drawing/2014/main" id="{0DF63642-AA6D-483D-A0F0-564D9C9F47BC}"/>
+                <a16:creationId xmlns:a16="http://schemas.microsoft.com/office/drawing/2014/main" id="{A25A003F-3438-4C8D-B621-1CEC09C57CBB}"/>
               </a:ext>
             </a:extLst>
           </p:cNvPr>
@@ -9852,7 +9852,7 @@
           <p:cNvPr id="9" name="">
             <a:extLst xmlns:a="http://schemas.openxmlformats.org/drawingml/2006/main">
               <a:ext uri="{FF2B5EF4-FFF2-40B4-BE49-F238E27FC236}">
-                <a16:creationId xmlns:a16="http://schemas.microsoft.com/office/drawing/2014/main" id="{2E14A875-2963-406E-9E5B-0EC41A128022}"/>
+                <a16:creationId xmlns:a16="http://schemas.microsoft.com/office/drawing/2014/main" id="{9401901E-72C8-4BD3-8EF7-32E0F97F7240}"/>
               </a:ext>
             </a:extLst>
           </p:cNvPr>
@@ -9922,7 +9922,7 @@
           <p:cNvPr id="10" name="">
             <a:extLst xmlns:a="http://schemas.openxmlformats.org/drawingml/2006/main">
               <a:ext uri="{FF2B5EF4-FFF2-40B4-BE49-F238E27FC236}">
-                <a16:creationId xmlns:a16="http://schemas.microsoft.com/office/drawing/2014/main" id="{6BFCC9A9-7029-4A14-AB71-D69FEA17080F}"/>
+                <a16:creationId xmlns:a16="http://schemas.microsoft.com/office/drawing/2014/main" id="{623FBEC4-E71F-45EB-AACC-FF3260164C6B}"/>
               </a:ext>
             </a:extLst>
           </p:cNvPr>
@@ -9992,7 +9992,7 @@
           <p:cNvPr id="14" name="">
             <a:extLst xmlns:a="http://schemas.openxmlformats.org/drawingml/2006/main">
               <a:ext uri="{FF2B5EF4-FFF2-40B4-BE49-F238E27FC236}">
-                <a16:creationId xmlns:a16="http://schemas.microsoft.com/office/drawing/2014/main" id="{7C96D78A-BDD0-4377-AC58-F11C1218C145}"/>
+                <a16:creationId xmlns:a16="http://schemas.microsoft.com/office/drawing/2014/main" id="{4119FF3E-DA91-4372-A41D-31117DFFCDC6}"/>
               </a:ext>
             </a:extLst>
           </p:cNvPr>
@@ -10058,7 +10058,7 @@
           <p:cNvPr id="15" name="">
             <a:extLst xmlns:a="http://schemas.openxmlformats.org/drawingml/2006/main">
               <a:ext uri="{FF2B5EF4-FFF2-40B4-BE49-F238E27FC236}">
-                <a16:creationId xmlns:a16="http://schemas.microsoft.com/office/drawing/2014/main" id="{751DAC6B-F87E-4400-B62B-B5AE55A95D0B}"/>
+                <a16:creationId xmlns:a16="http://schemas.microsoft.com/office/drawing/2014/main" id="{2DFAB845-D6F5-41D3-8BE6-8D9FDA876ECD}"/>
               </a:ext>
             </a:extLst>
           </p:cNvPr>
@@ -10124,7 +10124,7 @@
           <p:cNvPr id="16" name="">
             <a:extLst xmlns:a="http://schemas.openxmlformats.org/drawingml/2006/main">
               <a:ext uri="{FF2B5EF4-FFF2-40B4-BE49-F238E27FC236}">
-                <a16:creationId xmlns:a16="http://schemas.microsoft.com/office/drawing/2014/main" id="{5FC599A4-2719-43A4-AF38-CF0449491086}"/>
+                <a16:creationId xmlns:a16="http://schemas.microsoft.com/office/drawing/2014/main" id="{EDA8302B-F5C1-4927-BAF2-F16D385F1F39}"/>
               </a:ext>
             </a:extLst>
           </p:cNvPr>
@@ -10190,7 +10190,7 @@
           <p:cNvPr id="17" name="">
             <a:extLst xmlns:a="http://schemas.openxmlformats.org/drawingml/2006/main">
               <a:ext uri="{FF2B5EF4-FFF2-40B4-BE49-F238E27FC236}">
-                <a16:creationId xmlns:a16="http://schemas.microsoft.com/office/drawing/2014/main" id="{BFDCF359-8F7A-42A2-BB8D-FA7A179E8FD8}"/>
+                <a16:creationId xmlns:a16="http://schemas.microsoft.com/office/drawing/2014/main" id="{7E339A6D-D1E3-467B-BA5C-284901B3C77E}"/>
               </a:ext>
             </a:extLst>
           </p:cNvPr>
@@ -10254,7 +10254,7 @@
     </p:spTree>
     <p:extLst>
       <p:ext uri="{BB962C8B-B14F-4D97-AF65-F5344CB8AC3E}">
-        <p14:creationId xmlns:p14="http://schemas.microsoft.com/office/powerpoint/2010/main" val="883529082"/>
+        <p14:creationId xmlns:p14="http://schemas.microsoft.com/office/powerpoint/2010/main" val="145176812"/>
       </p:ext>
     </p:extLst>
   </p:cSld>
@@ -10285,7 +10285,7 @@
           <p:cNvPr id="7" name="">
             <a:extLst xmlns:a="http://schemas.openxmlformats.org/drawingml/2006/main">
               <a:ext uri="{FF2B5EF4-FFF2-40B4-BE49-F238E27FC236}">
-                <a16:creationId xmlns:a16="http://schemas.microsoft.com/office/drawing/2014/main" id="{7ED4BB63-A507-4EF4-A415-A24F340B13FB}"/>
+                <a16:creationId xmlns:a16="http://schemas.microsoft.com/office/drawing/2014/main" id="{3452B7DA-64F3-44CA-872D-7376913306D6}"/>
               </a:ext>
             </a:extLst>
           </p:cNvPr>
@@ -10351,7 +10351,7 @@
           <p:cNvPr id="2" name="">
             <a:extLst xmlns:a="http://schemas.openxmlformats.org/drawingml/2006/main">
               <a:ext uri="{FF2B5EF4-FFF2-40B4-BE49-F238E27FC236}">
-                <a16:creationId xmlns:a16="http://schemas.microsoft.com/office/drawing/2014/main" id="{797C9001-7B27-4671-9E9C-5550E5659423}"/>
+                <a16:creationId xmlns:a16="http://schemas.microsoft.com/office/drawing/2014/main" id="{2B459AE8-74EE-44D2-A84F-11C0E9615ED5}"/>
               </a:ext>
             </a:extLst>
           </p:cNvPr>
@@ -10417,7 +10417,7 @@
           <p:cNvPr id="3" name="">
             <a:extLst xmlns:a="http://schemas.openxmlformats.org/drawingml/2006/main">
               <a:ext uri="{FF2B5EF4-FFF2-40B4-BE49-F238E27FC236}">
-                <a16:creationId xmlns:a16="http://schemas.microsoft.com/office/drawing/2014/main" id="{455F98A4-435B-4B20-AB2B-C0736287E7BF}"/>
+                <a16:creationId xmlns:a16="http://schemas.microsoft.com/office/drawing/2014/main" id="{D09F34E9-DAF6-4C1B-8200-AFAA439A3197}"/>
               </a:ext>
             </a:extLst>
           </p:cNvPr>
@@ -10427,7 +10427,7 @@
           <p:nvPr/>
         </p:nvPicPr>
         <p:blipFill>
-          <a:blip xmlns:r="http://schemas.openxmlformats.org/officeDocument/2006/relationships" xmlns:a="http://schemas.openxmlformats.org/drawingml/2006/main" r:embed="R4a573b5bfdee4acc"/>
+          <a:blip xmlns:r="http://schemas.openxmlformats.org/officeDocument/2006/relationships" xmlns:a="http://schemas.openxmlformats.org/drawingml/2006/main" r:embed="R951a98bd8f7541ad"/>
           <a:stretch xmlns:a="http://schemas.openxmlformats.org/drawingml/2006/main"/>
         </p:blipFill>
         <p:spPr>
@@ -10445,7 +10445,7 @@
           <p:cNvPr id="4" name="">
             <a:extLst xmlns:a="http://schemas.openxmlformats.org/drawingml/2006/main">
               <a:ext uri="{FF2B5EF4-FFF2-40B4-BE49-F238E27FC236}">
-                <a16:creationId xmlns:a16="http://schemas.microsoft.com/office/drawing/2014/main" id="{4D11BED2-059D-4E89-9FBC-66388EF3B0A5}"/>
+                <a16:creationId xmlns:a16="http://schemas.microsoft.com/office/drawing/2014/main" id="{7B9F9629-11CF-4E35-9856-FA7CBA1C74E7}"/>
               </a:ext>
             </a:extLst>
           </p:cNvPr>
@@ -10511,7 +10511,7 @@
           <p:cNvPr id="5" name="">
             <a:extLst xmlns:a="http://schemas.openxmlformats.org/drawingml/2006/main">
               <a:ext uri="{FF2B5EF4-FFF2-40B4-BE49-F238E27FC236}">
-                <a16:creationId xmlns:a16="http://schemas.microsoft.com/office/drawing/2014/main" id="{53A9BE3C-8A49-4672-921D-F5BD9FD2DAFD}"/>
+                <a16:creationId xmlns:a16="http://schemas.microsoft.com/office/drawing/2014/main" id="{66F0CE23-8380-4276-A5F6-C8B5A21ECEA6}"/>
               </a:ext>
             </a:extLst>
           </p:cNvPr>
@@ -10600,7 +10600,7 @@
           <p:cNvPr id="6" name="">
             <a:extLst xmlns:a="http://schemas.openxmlformats.org/drawingml/2006/main">
               <a:ext uri="{FF2B5EF4-FFF2-40B4-BE49-F238E27FC236}">
-                <a16:creationId xmlns:a16="http://schemas.microsoft.com/office/drawing/2014/main" id="{114AD9C4-7FDD-4D25-B3F9-1C941956E812}"/>
+                <a16:creationId xmlns:a16="http://schemas.microsoft.com/office/drawing/2014/main" id="{98E2614B-A805-4583-ADED-55A0442415C3}"/>
               </a:ext>
             </a:extLst>
           </p:cNvPr>
@@ -10687,7 +10687,7 @@
     </p:spTree>
     <p:extLst>
       <p:ext uri="{BB962C8B-B14F-4D97-AF65-F5344CB8AC3E}">
-        <p14:creationId xmlns:p14="http://schemas.microsoft.com/office/powerpoint/2010/main" val="1266722349"/>
+        <p14:creationId xmlns:p14="http://schemas.microsoft.com/office/powerpoint/2010/main" val="1255425459"/>
       </p:ext>
     </p:extLst>
   </p:cSld>

</xml_diff>